<commit_message>
extraction de donnees dataElements CMA
</commit_message>
<xml_diff>
--- a/dataElements/PRESENTATION BILAN INDICATEURS RENCONTRE_ECD_RESP FS_SUS_CUT_S1_25_amendé_Haro.pptx
+++ b/dataElements/PRESENTATION BILAN INDICATEURS RENCONTRE_ECD_RESP FS_SUS_CUT_S1_25_amendé_Haro.pptx
@@ -15485,7 +15485,7 @@
           <p:nvPr>
             <p:extLst>
               <p:ext uri="{D42A27DB-BD31-4B8C-83A1-F6EECF244321}">
-                <p14:modId xmlns:p14="http://schemas.microsoft.com/office/powerpoint/2010/main" val="2640373957"/>
+                <p14:modId xmlns:p14="http://schemas.microsoft.com/office/powerpoint/2010/main" val="4109992160"/>
               </p:ext>
             </p:extLst>
           </p:nvPr>
@@ -18094,12 +18094,37 @@
                     <a:p>
                       <a:pPr algn="l" fontAlgn="b"/>
                       <a:r>
-                        <a:rPr lang="fr-FR" sz="1400" b="0" i="0" u="none" strike="noStrike">
-                          <a:effectLst/>
-                          <a:latin typeface="Arial" panose="020B0604020202020204" pitchFamily="34" charset="0"/>
-                        </a:rPr>
-                        <a:t>CMA Pissy: Consultation Externe Medecine Generale</a:t>
-                      </a:r>
+                        <a:rPr lang="fr-FR" sz="1400" b="0" i="0" u="none" strike="noStrike" dirty="0">
+                          <a:effectLst/>
+                          <a:latin typeface="Arial" panose="020B0604020202020204" pitchFamily="34" charset="0"/>
+                        </a:rPr>
+                        <a:t>CMA Pissy: Consultation Externe </a:t>
+                      </a:r>
+                      <a:r>
+                        <a:rPr lang="fr-FR" sz="1400" b="0" i="0" u="none" strike="noStrike" dirty="0" err="1">
+                          <a:effectLst/>
+                          <a:latin typeface="Arial" panose="020B0604020202020204" pitchFamily="34" charset="0"/>
+                        </a:rPr>
+                        <a:t>Medecine</a:t>
+                      </a:r>
+                      <a:r>
+                        <a:rPr lang="fr-FR" sz="1400" b="0" i="0" u="none" strike="noStrike" dirty="0">
+                          <a:effectLst/>
+                          <a:latin typeface="Arial" panose="020B0604020202020204" pitchFamily="34" charset="0"/>
+                        </a:rPr>
+                        <a:t> </a:t>
+                      </a:r>
+                      <a:r>
+                        <a:rPr lang="fr-FR" sz="1400" b="0" i="0" u="none" strike="noStrike" dirty="0" err="1">
+                          <a:effectLst/>
+                          <a:latin typeface="Arial" panose="020B0604020202020204" pitchFamily="34" charset="0"/>
+                        </a:rPr>
+                        <a:t>Generale</a:t>
+                      </a:r>
+                      <a:endParaRPr lang="fr-FR" sz="1400" b="0" i="0" u="none" strike="noStrike" dirty="0">
+                        <a:effectLst/>
+                        <a:latin typeface="Arial" panose="020B0604020202020204" pitchFamily="34" charset="0"/>
+                      </a:endParaRPr>
                     </a:p>
                   </a:txBody>
                   <a:tcPr marL="8822" marR="8822" marT="8822" marB="0" anchor="b">
@@ -18149,7 +18174,7 @@
                     <a:p>
                       <a:pPr algn="ctr" fontAlgn="ctr"/>
                       <a:r>
-                        <a:rPr lang="fr-FR" sz="1400" b="0" i="0" u="none" strike="noStrike">
+                        <a:rPr lang="fr-FR" sz="1400" b="0" i="0" u="none" strike="noStrike" dirty="0">
                           <a:effectLst/>
                           <a:latin typeface="Arial" panose="020B0604020202020204" pitchFamily="34" charset="0"/>
                         </a:rPr>
@@ -18204,7 +18229,7 @@
                     <a:p>
                       <a:pPr algn="ctr" fontAlgn="ctr"/>
                       <a:r>
-                        <a:rPr lang="fr-FR" sz="1400" b="0" i="0" u="none" strike="noStrike">
+                        <a:rPr lang="fr-FR" sz="1400" b="0" i="0" u="none" strike="noStrike" dirty="0">
                           <a:effectLst/>
                           <a:latin typeface="Arial" panose="020B0604020202020204" pitchFamily="34" charset="0"/>
                         </a:rPr>
@@ -18259,7 +18284,7 @@
                     <a:p>
                       <a:pPr algn="ctr" fontAlgn="ctr"/>
                       <a:r>
-                        <a:rPr lang="fr-FR" sz="1400" b="0" i="0" u="none" strike="noStrike">
+                        <a:rPr lang="fr-FR" sz="1400" b="0" i="0" u="none" strike="noStrike" dirty="0">
                           <a:effectLst/>
                           <a:latin typeface="Arial" panose="020B0604020202020204" pitchFamily="34" charset="0"/>
                         </a:rPr>
@@ -18314,7 +18339,7 @@
                     <a:p>
                       <a:pPr algn="ctr" fontAlgn="ctr"/>
                       <a:r>
-                        <a:rPr lang="fr-FR" sz="1400" b="0" i="0" u="none" strike="noStrike">
+                        <a:rPr lang="fr-FR" sz="1400" b="0" i="0" u="none" strike="noStrike" dirty="0">
                           <a:effectLst/>
                           <a:latin typeface="Arial" panose="020B0604020202020204" pitchFamily="34" charset="0"/>
                         </a:rPr>
@@ -18369,7 +18394,7 @@
                     <a:p>
                       <a:pPr algn="ctr" fontAlgn="ctr"/>
                       <a:r>
-                        <a:rPr lang="fr-FR" sz="1400" b="0" i="0" u="none" strike="noStrike">
+                        <a:rPr lang="fr-FR" sz="1400" b="0" i="0" u="none" strike="noStrike" dirty="0">
                           <a:effectLst/>
                           <a:latin typeface="Arial" panose="020B0604020202020204" pitchFamily="34" charset="0"/>
                         </a:rPr>
@@ -18424,7 +18449,7 @@
                     <a:p>
                       <a:pPr algn="ctr" fontAlgn="ctr"/>
                       <a:r>
-                        <a:rPr lang="fr-FR" sz="1400" b="0" i="0" u="none" strike="noStrike">
+                        <a:rPr lang="fr-FR" sz="1400" b="0" i="0" u="none" strike="noStrike" dirty="0">
                           <a:effectLst/>
                           <a:latin typeface="Arial" panose="020B0604020202020204" pitchFamily="34" charset="0"/>
                         </a:rPr>
@@ -18479,7 +18504,7 @@
                     <a:p>
                       <a:pPr algn="ctr" fontAlgn="ctr"/>
                       <a:r>
-                        <a:rPr lang="fr-FR" sz="1400" b="0" i="0" u="none" strike="noStrike">
+                        <a:rPr lang="fr-FR" sz="1400" b="0" i="0" u="none" strike="noStrike" dirty="0">
                           <a:effectLst/>
                           <a:latin typeface="Arial" panose="020B0604020202020204" pitchFamily="34" charset="0"/>
                         </a:rPr>
@@ -18752,7 +18777,7 @@
                     <a:p>
                       <a:pPr algn="ctr" fontAlgn="ctr"/>
                       <a:r>
-                        <a:rPr lang="fr-FR" sz="1400" b="0" i="0" u="none" strike="noStrike">
+                        <a:rPr lang="fr-FR" sz="1400" b="0" i="0" u="none" strike="noStrike" dirty="0">
                           <a:effectLst/>
                           <a:latin typeface="Arial" panose="020B0604020202020204" pitchFamily="34" charset="0"/>
                         </a:rPr>
@@ -19077,12 +19102,23 @@
                     <a:p>
                       <a:pPr algn="l" fontAlgn="b"/>
                       <a:r>
-                        <a:rPr lang="fr-FR" sz="1400" b="0" i="0" u="none" strike="noStrike">
-                          <a:effectLst/>
-                          <a:latin typeface="Arial" panose="020B0604020202020204" pitchFamily="34" charset="0"/>
-                        </a:rPr>
-                        <a:t>CMA Pissy: Maternite</a:t>
-                      </a:r>
+                        <a:rPr lang="fr-FR" sz="1400" b="0" i="0" u="none" strike="noStrike" dirty="0">
+                          <a:effectLst/>
+                          <a:latin typeface="Arial" panose="020B0604020202020204" pitchFamily="34" charset="0"/>
+                        </a:rPr>
+                        <a:t>CMA Pissy: </a:t>
+                      </a:r>
+                      <a:r>
+                        <a:rPr lang="fr-FR" sz="1400" b="0" i="0" u="none" strike="noStrike" dirty="0" err="1">
+                          <a:effectLst/>
+                          <a:latin typeface="Arial" panose="020B0604020202020204" pitchFamily="34" charset="0"/>
+                        </a:rPr>
+                        <a:t>Maternite</a:t>
+                      </a:r>
+                      <a:endParaRPr lang="fr-FR" sz="1400" b="0" i="0" u="none" strike="noStrike" dirty="0">
+                        <a:effectLst/>
+                        <a:latin typeface="Arial" panose="020B0604020202020204" pitchFamily="34" charset="0"/>
+                      </a:endParaRPr>
                     </a:p>
                   </a:txBody>
                   <a:tcPr marL="8822" marR="8822" marT="8822" marB="0" anchor="b">
@@ -19573,12 +19609,23 @@
                     <a:p>
                       <a:pPr algn="l" fontAlgn="b"/>
                       <a:r>
-                        <a:rPr lang="fr-FR" sz="1400" b="0" i="0" u="none" strike="noStrike">
-                          <a:effectLst/>
-                          <a:latin typeface="Arial" panose="020B0604020202020204" pitchFamily="34" charset="0"/>
-                        </a:rPr>
-                        <a:t>CMA Pissy: Medecine</a:t>
-                      </a:r>
+                        <a:rPr lang="fr-FR" sz="1400" b="0" i="0" u="none" strike="noStrike" dirty="0">
+                          <a:effectLst/>
+                          <a:latin typeface="Arial" panose="020B0604020202020204" pitchFamily="34" charset="0"/>
+                        </a:rPr>
+                        <a:t>CMA Pissy: </a:t>
+                      </a:r>
+                      <a:r>
+                        <a:rPr lang="fr-FR" sz="1400" b="0" i="0" u="none" strike="noStrike" dirty="0" err="1">
+                          <a:effectLst/>
+                          <a:latin typeface="Arial" panose="020B0604020202020204" pitchFamily="34" charset="0"/>
+                        </a:rPr>
+                        <a:t>Medecine</a:t>
+                      </a:r>
+                      <a:endParaRPr lang="fr-FR" sz="1400" b="0" i="0" u="none" strike="noStrike" dirty="0">
+                        <a:effectLst/>
+                        <a:latin typeface="Arial" panose="020B0604020202020204" pitchFamily="34" charset="0"/>
+                      </a:endParaRPr>
                     </a:p>
                   </a:txBody>
                   <a:tcPr marL="8822" marR="8822" marT="8822" marB="0" anchor="b">
@@ -19628,7 +19675,7 @@
                     <a:p>
                       <a:pPr algn="ctr" fontAlgn="ctr"/>
                       <a:r>
-                        <a:rPr lang="fr-FR" sz="1400" b="0" i="0" u="none" strike="noStrike">
+                        <a:rPr lang="fr-FR" sz="1400" b="0" i="0" u="none" strike="noStrike" dirty="0">
                           <a:effectLst/>
                           <a:latin typeface="Arial" panose="020B0604020202020204" pitchFamily="34" charset="0"/>
                         </a:rPr>
@@ -19683,7 +19730,7 @@
                     <a:p>
                       <a:pPr algn="ctr" fontAlgn="ctr"/>
                       <a:r>
-                        <a:rPr lang="fr-FR" sz="1400" b="0" i="0" u="none" strike="noStrike">
+                        <a:rPr lang="fr-FR" sz="1400" b="0" i="0" u="none" strike="noStrike" dirty="0">
                           <a:effectLst/>
                           <a:latin typeface="Arial" panose="020B0604020202020204" pitchFamily="34" charset="0"/>
                         </a:rPr>
@@ -19738,7 +19785,7 @@
                     <a:p>
                       <a:pPr algn="ctr" fontAlgn="ctr"/>
                       <a:r>
-                        <a:rPr lang="fr-FR" sz="1400" b="0" i="0" u="none" strike="noStrike">
+                        <a:rPr lang="fr-FR" sz="1400" b="0" i="0" u="none" strike="noStrike" dirty="0">
                           <a:effectLst/>
                           <a:latin typeface="Arial" panose="020B0604020202020204" pitchFamily="34" charset="0"/>
                         </a:rPr>
@@ -19793,7 +19840,7 @@
                     <a:p>
                       <a:pPr algn="ctr" fontAlgn="ctr"/>
                       <a:r>
-                        <a:rPr lang="fr-FR" sz="1400" b="0" i="0" u="none" strike="noStrike">
+                        <a:rPr lang="fr-FR" sz="1400" b="0" i="0" u="none" strike="noStrike" dirty="0">
                           <a:effectLst/>
                           <a:latin typeface="Arial" panose="020B0604020202020204" pitchFamily="34" charset="0"/>
                         </a:rPr>
@@ -19848,7 +19895,7 @@
                     <a:p>
                       <a:pPr algn="ctr" fontAlgn="ctr"/>
                       <a:r>
-                        <a:rPr lang="fr-FR" sz="1400" b="0" i="0" u="none" strike="noStrike">
+                        <a:rPr lang="fr-FR" sz="1400" b="0" i="0" u="none" strike="noStrike" dirty="0">
                           <a:effectLst/>
                           <a:latin typeface="Arial" panose="020B0604020202020204" pitchFamily="34" charset="0"/>
                         </a:rPr>
@@ -19903,7 +19950,7 @@
                     <a:p>
                       <a:pPr algn="ctr" fontAlgn="ctr"/>
                       <a:r>
-                        <a:rPr lang="fr-FR" sz="1400" b="0" i="0" u="none" strike="noStrike">
+                        <a:rPr lang="fr-FR" sz="1400" b="0" i="0" u="none" strike="noStrike" dirty="0">
                           <a:effectLst/>
                           <a:latin typeface="Arial" panose="020B0604020202020204" pitchFamily="34" charset="0"/>
                         </a:rPr>
@@ -19958,7 +20005,7 @@
                     <a:p>
                       <a:pPr algn="ctr" fontAlgn="ctr"/>
                       <a:r>
-                        <a:rPr lang="fr-FR" sz="1400" b="0" i="0" u="none" strike="noStrike">
+                        <a:rPr lang="fr-FR" sz="1400" b="0" i="0" u="none" strike="noStrike" dirty="0">
                           <a:effectLst/>
                           <a:latin typeface="Arial" panose="020B0604020202020204" pitchFamily="34" charset="0"/>
                         </a:rPr>
@@ -20013,7 +20060,7 @@
                     <a:p>
                       <a:pPr algn="ctr" fontAlgn="ctr"/>
                       <a:r>
-                        <a:rPr lang="fr-FR" sz="1400" b="0" i="0" u="none" strike="noStrike">
+                        <a:rPr lang="fr-FR" sz="1400" b="0" i="0" u="none" strike="noStrike" dirty="0">
                           <a:effectLst/>
                           <a:latin typeface="Arial" panose="020B0604020202020204" pitchFamily="34" charset="0"/>
                         </a:rPr>
@@ -20063,15 +20110,84 @@
                     <a:p>
                       <a:pPr algn="l" fontAlgn="b"/>
                       <a:r>
+                        <a:rPr lang="fr-FR" sz="1400" b="0" i="0" u="none" strike="noStrike" dirty="0">
+                          <a:effectLst/>
+                          <a:latin typeface="Arial" panose="020B0604020202020204" pitchFamily="34" charset="0"/>
+                        </a:rPr>
+                        <a:t>CMA Pissy: </a:t>
+                      </a:r>
+                      <a:r>
+                        <a:rPr lang="fr-FR" sz="1400" b="0" i="0" u="none" strike="noStrike" dirty="0" err="1">
+                          <a:effectLst/>
+                          <a:latin typeface="Arial" panose="020B0604020202020204" pitchFamily="34" charset="0"/>
+                        </a:rPr>
+                        <a:t>Medecine</a:t>
+                      </a:r>
+                      <a:r>
+                        <a:rPr lang="fr-FR" sz="1400" b="0" i="0" u="none" strike="noStrike" dirty="0">
+                          <a:effectLst/>
+                          <a:latin typeface="Arial" panose="020B0604020202020204" pitchFamily="34" charset="0"/>
+                        </a:rPr>
+                        <a:t> Interne</a:t>
+                      </a:r>
+                    </a:p>
+                  </a:txBody>
+                  <a:tcPr marL="8822" marR="8822" marT="8822" marB="0" anchor="b">
+                    <a:lnL w="6350" cap="flat" cmpd="sng" algn="ctr">
+                      <a:noFill/>
+                      <a:prstDash val="solid"/>
+                      <a:round/>
+                      <a:headEnd type="none" w="med" len="med"/>
+                      <a:tailEnd type="none" w="med" len="med"/>
+                    </a:lnL>
+                    <a:lnR w="6350" cap="flat" cmpd="sng" algn="ctr">
+                      <a:noFill/>
+                      <a:prstDash val="solid"/>
+                      <a:round/>
+                      <a:headEnd type="none" w="med" len="med"/>
+                      <a:tailEnd type="none" w="med" len="med"/>
+                    </a:lnR>
+                    <a:lnT w="6350" cap="flat" cmpd="sng" algn="ctr">
+                      <a:noFill/>
+                      <a:prstDash val="solid"/>
+                      <a:round/>
+                      <a:headEnd type="none" w="med" len="med"/>
+                      <a:tailEnd type="none" w="med" len="med"/>
+                    </a:lnT>
+                    <a:lnB w="6350" cap="flat" cmpd="sng" algn="ctr">
+                      <a:noFill/>
+                      <a:prstDash val="solid"/>
+                      <a:round/>
+                      <a:headEnd type="none" w="med" len="med"/>
+                      <a:tailEnd type="none" w="med" len="med"/>
+                    </a:lnB>
+                    <a:lnTlToBr w="12700" cmpd="sng">
+                      <a:noFill/>
+                      <a:prstDash val="solid"/>
+                    </a:lnTlToBr>
+                    <a:lnBlToTr w="12700" cmpd="sng">
+                      <a:noFill/>
+                      <a:prstDash val="solid"/>
+                    </a:lnBlToTr>
+                    <a:noFill/>
+                  </a:tcPr>
+                </a:tc>
+                <a:tc>
+                  <a:txBody>
+                    <a:bodyPr/>
+                    <a:lstStyle/>
+                    <a:p>
+                      <a:pPr algn="ctr" fontAlgn="ctr"/>
+                      <a:r>
                         <a:rPr lang="fr-FR" sz="1400" b="0" i="0" u="none" strike="noStrike">
                           <a:effectLst/>
                           <a:latin typeface="Arial" panose="020B0604020202020204" pitchFamily="34" charset="0"/>
                         </a:rPr>
-                        <a:t>CMA Pissy: Medecine Interne</a:t>
-                      </a:r>
-                    </a:p>
-                  </a:txBody>
-                  <a:tcPr marL="8822" marR="8822" marT="8822" marB="0" anchor="b">
+                        <a:t> </a:t>
+                      </a:r>
+                    </a:p>
+                  </a:txBody>
+                  <a:tcPr marL="8822" marR="8822" marT="8822" marB="0" anchor="ctr">
                     <a:lnL w="6350" cap="flat" cmpd="sng" algn="ctr">
                       <a:noFill/>
                       <a:prstDash val="solid"/>
@@ -20232,7 +20348,7 @@
                           <a:effectLst/>
                           <a:latin typeface="Arial" panose="020B0604020202020204" pitchFamily="34" charset="0"/>
                         </a:rPr>
-                        <a:t> </a:t>
+                        <a:t>0</a:t>
                       </a:r>
                     </a:p>
                   </a:txBody>
@@ -20397,7 +20513,7 @@
                           <a:effectLst/>
                           <a:latin typeface="Arial" panose="020B0604020202020204" pitchFamily="34" charset="0"/>
                         </a:rPr>
-                        <a:t>0</a:t>
+                        <a:t>353</a:t>
                       </a:r>
                     </a:p>
                   </a:txBody>
@@ -20448,62 +20564,7 @@
                     <a:p>
                       <a:pPr algn="ctr" fontAlgn="ctr"/>
                       <a:r>
-                        <a:rPr lang="fr-FR" sz="1400" b="0" i="0" u="none" strike="noStrike">
-                          <a:effectLst/>
-                          <a:latin typeface="Arial" panose="020B0604020202020204" pitchFamily="34" charset="0"/>
-                        </a:rPr>
-                        <a:t>353</a:t>
-                      </a:r>
-                    </a:p>
-                  </a:txBody>
-                  <a:tcPr marL="8822" marR="8822" marT="8822" marB="0" anchor="ctr">
-                    <a:lnL w="6350" cap="flat" cmpd="sng" algn="ctr">
-                      <a:noFill/>
-                      <a:prstDash val="solid"/>
-                      <a:round/>
-                      <a:headEnd type="none" w="med" len="med"/>
-                      <a:tailEnd type="none" w="med" len="med"/>
-                    </a:lnL>
-                    <a:lnR w="6350" cap="flat" cmpd="sng" algn="ctr">
-                      <a:noFill/>
-                      <a:prstDash val="solid"/>
-                      <a:round/>
-                      <a:headEnd type="none" w="med" len="med"/>
-                      <a:tailEnd type="none" w="med" len="med"/>
-                    </a:lnR>
-                    <a:lnT w="6350" cap="flat" cmpd="sng" algn="ctr">
-                      <a:noFill/>
-                      <a:prstDash val="solid"/>
-                      <a:round/>
-                      <a:headEnd type="none" w="med" len="med"/>
-                      <a:tailEnd type="none" w="med" len="med"/>
-                    </a:lnT>
-                    <a:lnB w="6350" cap="flat" cmpd="sng" algn="ctr">
-                      <a:noFill/>
-                      <a:prstDash val="solid"/>
-                      <a:round/>
-                      <a:headEnd type="none" w="med" len="med"/>
-                      <a:tailEnd type="none" w="med" len="med"/>
-                    </a:lnB>
-                    <a:lnTlToBr w="12700" cmpd="sng">
-                      <a:noFill/>
-                      <a:prstDash val="solid"/>
-                    </a:lnTlToBr>
-                    <a:lnBlToTr w="12700" cmpd="sng">
-                      <a:noFill/>
-                      <a:prstDash val="solid"/>
-                    </a:lnBlToTr>
-                    <a:noFill/>
-                  </a:tcPr>
-                </a:tc>
-                <a:tc>
-                  <a:txBody>
-                    <a:bodyPr/>
-                    <a:lstStyle/>
-                    <a:p>
-                      <a:pPr algn="ctr" fontAlgn="ctr"/>
-                      <a:r>
-                        <a:rPr lang="fr-FR" sz="1400" b="0" i="0" u="none" strike="noStrike">
+                        <a:rPr lang="fr-FR" sz="1400" b="0" i="0" u="none" strike="noStrike" dirty="0">
                           <a:solidFill>
                             <a:srgbClr val="FF0000"/>
                           </a:solidFill>

</xml_diff>